<commit_message>
Keep demo video under three minutes
</commit_message>
<xml_diff>
--- a/黑客松参赛区/最终提交材料/篮球技术台自动化_三分钟演示视频源.pptx
+++ b/黑客松参赛区/最终提交材料/篮球技术台自动化_三分钟演示视频源.pptx
@@ -140,7 +140,7 @@
           <p:cNvPr id="2" name="标题 1">
             <a:extLst>
               <a:ext uri="{FF2B5EF4-FFF2-40B4-BE49-F238E27FC236}">
-                <a16:creationId xmlns:a16="http://schemas.microsoft.com/office/drawing/2014/main" id="{082D770F-340E-3A17-FA6B-D6E0324AABCF}"/>
+                <a16:creationId xmlns:a16="http://schemas.microsoft.com/office/drawing/2014/main" id="{C1B30A18-B126-5990-F5DF-BB973FB155E0}"/>
               </a:ext>
             </a:extLst>
           </p:cNvPr>
@@ -177,7 +177,7 @@
           <p:cNvPr id="3" name="副标题 2">
             <a:extLst>
               <a:ext uri="{FF2B5EF4-FFF2-40B4-BE49-F238E27FC236}">
-                <a16:creationId xmlns:a16="http://schemas.microsoft.com/office/drawing/2014/main" id="{B4C8DF3B-D302-F785-96CD-1048AC241C1E}"/>
+                <a16:creationId xmlns:a16="http://schemas.microsoft.com/office/drawing/2014/main" id="{ACD61805-03E6-F912-8079-4C681289B105}"/>
               </a:ext>
             </a:extLst>
           </p:cNvPr>
@@ -247,7 +247,7 @@
           <p:cNvPr id="4" name="日期占位符 3">
             <a:extLst>
               <a:ext uri="{FF2B5EF4-FFF2-40B4-BE49-F238E27FC236}">
-                <a16:creationId xmlns:a16="http://schemas.microsoft.com/office/drawing/2014/main" id="{C3A46C28-090F-E982-5C1B-819E23D13504}"/>
+                <a16:creationId xmlns:a16="http://schemas.microsoft.com/office/drawing/2014/main" id="{5231D444-08F3-DBF2-DA27-21D306DBE335}"/>
               </a:ext>
             </a:extLst>
           </p:cNvPr>
@@ -263,7 +263,7 @@
           <a:bodyPr/>
           <a:lstStyle/>
           <a:p>
-            <a:fld id="{0B445544-D620-40E2-91EB-0E889D68CA9F}" type="datetimeFigureOut">
+            <a:fld id="{385F2371-EB98-4558-954D-418B83EB5BE7}" type="datetimeFigureOut">
               <a:rPr lang="zh-CN" altLang="en-US" smtClean="0"/>
               <a:t>2026-05-23</a:t>
             </a:fld>
@@ -276,7 +276,7 @@
           <p:cNvPr id="5" name="页脚占位符 4">
             <a:extLst>
               <a:ext uri="{FF2B5EF4-FFF2-40B4-BE49-F238E27FC236}">
-                <a16:creationId xmlns:a16="http://schemas.microsoft.com/office/drawing/2014/main" id="{73B37666-E149-229F-F2B1-ACC0344BF5F4}"/>
+                <a16:creationId xmlns:a16="http://schemas.microsoft.com/office/drawing/2014/main" id="{A7051595-DE22-9FC0-B71E-E324792B46BF}"/>
               </a:ext>
             </a:extLst>
           </p:cNvPr>
@@ -301,7 +301,7 @@
           <p:cNvPr id="6" name="灯片编号占位符 5">
             <a:extLst>
               <a:ext uri="{FF2B5EF4-FFF2-40B4-BE49-F238E27FC236}">
-                <a16:creationId xmlns:a16="http://schemas.microsoft.com/office/drawing/2014/main" id="{E6E6C2CC-EBF2-49DB-CB1E-E49A6BB3FC3C}"/>
+                <a16:creationId xmlns:a16="http://schemas.microsoft.com/office/drawing/2014/main" id="{22AFE83E-5761-6B2B-6178-19C32C4165E8}"/>
               </a:ext>
             </a:extLst>
           </p:cNvPr>
@@ -317,7 +317,7 @@
           <a:bodyPr/>
           <a:lstStyle/>
           <a:p>
-            <a:fld id="{DD4C1154-42D3-4374-80F5-2BFDBA7E201F}" type="slidenum">
+            <a:fld id="{C4CCB2AA-4365-4CE6-A0E4-B3B886E50B42}" type="slidenum">
               <a:rPr lang="zh-CN" altLang="en-US" smtClean="0"/>
               <a:t>‹#›</a:t>
             </a:fld>
@@ -328,7 +328,7 @@
     </p:spTree>
     <p:extLst>
       <p:ext uri="{BB962C8B-B14F-4D97-AF65-F5344CB8AC3E}">
-        <p14:creationId xmlns:p14="http://schemas.microsoft.com/office/powerpoint/2010/main" val="1697465874"/>
+        <p14:creationId xmlns:p14="http://schemas.microsoft.com/office/powerpoint/2010/main" val="1788363523"/>
       </p:ext>
     </p:extLst>
   </p:cSld>
@@ -360,7 +360,7 @@
           <p:cNvPr id="2" name="标题 1">
             <a:extLst>
               <a:ext uri="{FF2B5EF4-FFF2-40B4-BE49-F238E27FC236}">
-                <a16:creationId xmlns:a16="http://schemas.microsoft.com/office/drawing/2014/main" id="{6C0035DC-680F-8FF3-7BD5-4BD465034E9B}"/>
+                <a16:creationId xmlns:a16="http://schemas.microsoft.com/office/drawing/2014/main" id="{5875C9D6-79F8-ECD8-4D94-BB2876D9732D}"/>
               </a:ext>
             </a:extLst>
           </p:cNvPr>
@@ -388,7 +388,7 @@
           <p:cNvPr id="3" name="竖排文字占位符 2">
             <a:extLst>
               <a:ext uri="{FF2B5EF4-FFF2-40B4-BE49-F238E27FC236}">
-                <a16:creationId xmlns:a16="http://schemas.microsoft.com/office/drawing/2014/main" id="{A09F2B50-9023-D9E7-34F7-A3BA69BE0D8A}"/>
+                <a16:creationId xmlns:a16="http://schemas.microsoft.com/office/drawing/2014/main" id="{25162CB1-E098-9867-D8B4-8EA6B92D04DB}"/>
               </a:ext>
             </a:extLst>
           </p:cNvPr>
@@ -445,7 +445,7 @@
           <p:cNvPr id="4" name="日期占位符 3">
             <a:extLst>
               <a:ext uri="{FF2B5EF4-FFF2-40B4-BE49-F238E27FC236}">
-                <a16:creationId xmlns:a16="http://schemas.microsoft.com/office/drawing/2014/main" id="{493B2459-536A-4433-AC3F-46E1E59DA63A}"/>
+                <a16:creationId xmlns:a16="http://schemas.microsoft.com/office/drawing/2014/main" id="{6BF1D990-A263-BD75-6722-406B82064D5E}"/>
               </a:ext>
             </a:extLst>
           </p:cNvPr>
@@ -461,7 +461,7 @@
           <a:bodyPr/>
           <a:lstStyle/>
           <a:p>
-            <a:fld id="{0B445544-D620-40E2-91EB-0E889D68CA9F}" type="datetimeFigureOut">
+            <a:fld id="{385F2371-EB98-4558-954D-418B83EB5BE7}" type="datetimeFigureOut">
               <a:rPr lang="zh-CN" altLang="en-US" smtClean="0"/>
               <a:t>2026-05-23</a:t>
             </a:fld>
@@ -474,7 +474,7 @@
           <p:cNvPr id="5" name="页脚占位符 4">
             <a:extLst>
               <a:ext uri="{FF2B5EF4-FFF2-40B4-BE49-F238E27FC236}">
-                <a16:creationId xmlns:a16="http://schemas.microsoft.com/office/drawing/2014/main" id="{042EE9D3-7EC1-DCA5-17D3-01421086B1B8}"/>
+                <a16:creationId xmlns:a16="http://schemas.microsoft.com/office/drawing/2014/main" id="{11A1FAE0-1DE9-FB89-7BBC-37953B009123}"/>
               </a:ext>
             </a:extLst>
           </p:cNvPr>
@@ -499,7 +499,7 @@
           <p:cNvPr id="6" name="灯片编号占位符 5">
             <a:extLst>
               <a:ext uri="{FF2B5EF4-FFF2-40B4-BE49-F238E27FC236}">
-                <a16:creationId xmlns:a16="http://schemas.microsoft.com/office/drawing/2014/main" id="{C4A5F675-A8EF-2ABC-8FD5-7D60D9BBEE10}"/>
+                <a16:creationId xmlns:a16="http://schemas.microsoft.com/office/drawing/2014/main" id="{6A2BDFBA-DEE5-8C08-CA77-18985C2929C1}"/>
               </a:ext>
             </a:extLst>
           </p:cNvPr>
@@ -515,7 +515,7 @@
           <a:bodyPr/>
           <a:lstStyle/>
           <a:p>
-            <a:fld id="{DD4C1154-42D3-4374-80F5-2BFDBA7E201F}" type="slidenum">
+            <a:fld id="{C4CCB2AA-4365-4CE6-A0E4-B3B886E50B42}" type="slidenum">
               <a:rPr lang="zh-CN" altLang="en-US" smtClean="0"/>
               <a:t>‹#›</a:t>
             </a:fld>
@@ -526,7 +526,7 @@
     </p:spTree>
     <p:extLst>
       <p:ext uri="{BB962C8B-B14F-4D97-AF65-F5344CB8AC3E}">
-        <p14:creationId xmlns:p14="http://schemas.microsoft.com/office/powerpoint/2010/main" val="3479016002"/>
+        <p14:creationId xmlns:p14="http://schemas.microsoft.com/office/powerpoint/2010/main" val="3974942368"/>
       </p:ext>
     </p:extLst>
   </p:cSld>
@@ -558,7 +558,7 @@
           <p:cNvPr id="2" name="竖排标题 1">
             <a:extLst>
               <a:ext uri="{FF2B5EF4-FFF2-40B4-BE49-F238E27FC236}">
-                <a16:creationId xmlns:a16="http://schemas.microsoft.com/office/drawing/2014/main" id="{18B237C8-B3AA-AB94-7EF0-467F078E9A8E}"/>
+                <a16:creationId xmlns:a16="http://schemas.microsoft.com/office/drawing/2014/main" id="{5B9C8DE9-4453-A446-B139-279FD64C1ABA}"/>
               </a:ext>
             </a:extLst>
           </p:cNvPr>
@@ -591,7 +591,7 @@
           <p:cNvPr id="3" name="竖排文字占位符 2">
             <a:extLst>
               <a:ext uri="{FF2B5EF4-FFF2-40B4-BE49-F238E27FC236}">
-                <a16:creationId xmlns:a16="http://schemas.microsoft.com/office/drawing/2014/main" id="{A98D6820-6851-3E31-7264-5F4BBA9D8219}"/>
+                <a16:creationId xmlns:a16="http://schemas.microsoft.com/office/drawing/2014/main" id="{C3AF7FA6-36F4-9723-E8CD-454B7F845C3F}"/>
               </a:ext>
             </a:extLst>
           </p:cNvPr>
@@ -653,7 +653,7 @@
           <p:cNvPr id="4" name="日期占位符 3">
             <a:extLst>
               <a:ext uri="{FF2B5EF4-FFF2-40B4-BE49-F238E27FC236}">
-                <a16:creationId xmlns:a16="http://schemas.microsoft.com/office/drawing/2014/main" id="{8AED1264-49DB-0320-464C-14A2960441EB}"/>
+                <a16:creationId xmlns:a16="http://schemas.microsoft.com/office/drawing/2014/main" id="{2D4BF201-010C-298C-499D-4FF29A0FFB33}"/>
               </a:ext>
             </a:extLst>
           </p:cNvPr>
@@ -669,7 +669,7 @@
           <a:bodyPr/>
           <a:lstStyle/>
           <a:p>
-            <a:fld id="{0B445544-D620-40E2-91EB-0E889D68CA9F}" type="datetimeFigureOut">
+            <a:fld id="{385F2371-EB98-4558-954D-418B83EB5BE7}" type="datetimeFigureOut">
               <a:rPr lang="zh-CN" altLang="en-US" smtClean="0"/>
               <a:t>2026-05-23</a:t>
             </a:fld>
@@ -682,7 +682,7 @@
           <p:cNvPr id="5" name="页脚占位符 4">
             <a:extLst>
               <a:ext uri="{FF2B5EF4-FFF2-40B4-BE49-F238E27FC236}">
-                <a16:creationId xmlns:a16="http://schemas.microsoft.com/office/drawing/2014/main" id="{E8327364-96D7-F261-4DA0-AD104C3BD186}"/>
+                <a16:creationId xmlns:a16="http://schemas.microsoft.com/office/drawing/2014/main" id="{A8D8C2A8-9438-9390-E53C-115E392FFCFB}"/>
               </a:ext>
             </a:extLst>
           </p:cNvPr>
@@ -707,7 +707,7 @@
           <p:cNvPr id="6" name="灯片编号占位符 5">
             <a:extLst>
               <a:ext uri="{FF2B5EF4-FFF2-40B4-BE49-F238E27FC236}">
-                <a16:creationId xmlns:a16="http://schemas.microsoft.com/office/drawing/2014/main" id="{A32C4087-B72D-C851-DB06-9EED1AC30D30}"/>
+                <a16:creationId xmlns:a16="http://schemas.microsoft.com/office/drawing/2014/main" id="{FF6A46B3-19F5-40B3-DF0B-7134D71D8539}"/>
               </a:ext>
             </a:extLst>
           </p:cNvPr>
@@ -723,7 +723,7 @@
           <a:bodyPr/>
           <a:lstStyle/>
           <a:p>
-            <a:fld id="{DD4C1154-42D3-4374-80F5-2BFDBA7E201F}" type="slidenum">
+            <a:fld id="{C4CCB2AA-4365-4CE6-A0E4-B3B886E50B42}" type="slidenum">
               <a:rPr lang="zh-CN" altLang="en-US" smtClean="0"/>
               <a:t>‹#›</a:t>
             </a:fld>
@@ -734,7 +734,7 @@
     </p:spTree>
     <p:extLst>
       <p:ext uri="{BB962C8B-B14F-4D97-AF65-F5344CB8AC3E}">
-        <p14:creationId xmlns:p14="http://schemas.microsoft.com/office/powerpoint/2010/main" val="1314925159"/>
+        <p14:creationId xmlns:p14="http://schemas.microsoft.com/office/powerpoint/2010/main" val="4290533440"/>
       </p:ext>
     </p:extLst>
   </p:cSld>
@@ -766,7 +766,7 @@
           <p:cNvPr id="2" name="标题 1">
             <a:extLst>
               <a:ext uri="{FF2B5EF4-FFF2-40B4-BE49-F238E27FC236}">
-                <a16:creationId xmlns:a16="http://schemas.microsoft.com/office/drawing/2014/main" id="{0897887B-5877-B607-B2A5-50CD62919200}"/>
+                <a16:creationId xmlns:a16="http://schemas.microsoft.com/office/drawing/2014/main" id="{DB8B640B-628D-9486-747E-2B6338F7AF7C}"/>
               </a:ext>
             </a:extLst>
           </p:cNvPr>
@@ -794,7 +794,7 @@
           <p:cNvPr id="3" name="内容占位符 2">
             <a:extLst>
               <a:ext uri="{FF2B5EF4-FFF2-40B4-BE49-F238E27FC236}">
-                <a16:creationId xmlns:a16="http://schemas.microsoft.com/office/drawing/2014/main" id="{C377391F-8110-164C-29CD-6D6F04BCEE9A}"/>
+                <a16:creationId xmlns:a16="http://schemas.microsoft.com/office/drawing/2014/main" id="{CA37A81A-FC1E-6416-6D03-DBDEFCA0AD0D}"/>
               </a:ext>
             </a:extLst>
           </p:cNvPr>
@@ -851,7 +851,7 @@
           <p:cNvPr id="4" name="日期占位符 3">
             <a:extLst>
               <a:ext uri="{FF2B5EF4-FFF2-40B4-BE49-F238E27FC236}">
-                <a16:creationId xmlns:a16="http://schemas.microsoft.com/office/drawing/2014/main" id="{09C891A8-35AB-740A-46AD-3688C75F86CA}"/>
+                <a16:creationId xmlns:a16="http://schemas.microsoft.com/office/drawing/2014/main" id="{E1C09C56-6A69-737A-0F09-B5912BD39436}"/>
               </a:ext>
             </a:extLst>
           </p:cNvPr>
@@ -867,7 +867,7 @@
           <a:bodyPr/>
           <a:lstStyle/>
           <a:p>
-            <a:fld id="{0B445544-D620-40E2-91EB-0E889D68CA9F}" type="datetimeFigureOut">
+            <a:fld id="{385F2371-EB98-4558-954D-418B83EB5BE7}" type="datetimeFigureOut">
               <a:rPr lang="zh-CN" altLang="en-US" smtClean="0"/>
               <a:t>2026-05-23</a:t>
             </a:fld>
@@ -880,7 +880,7 @@
           <p:cNvPr id="5" name="页脚占位符 4">
             <a:extLst>
               <a:ext uri="{FF2B5EF4-FFF2-40B4-BE49-F238E27FC236}">
-                <a16:creationId xmlns:a16="http://schemas.microsoft.com/office/drawing/2014/main" id="{3A73A3F4-89B9-FD48-A332-B05389E26F66}"/>
+                <a16:creationId xmlns:a16="http://schemas.microsoft.com/office/drawing/2014/main" id="{A9134869-3EEA-EC87-7939-183958E5F592}"/>
               </a:ext>
             </a:extLst>
           </p:cNvPr>
@@ -905,7 +905,7 @@
           <p:cNvPr id="6" name="灯片编号占位符 5">
             <a:extLst>
               <a:ext uri="{FF2B5EF4-FFF2-40B4-BE49-F238E27FC236}">
-                <a16:creationId xmlns:a16="http://schemas.microsoft.com/office/drawing/2014/main" id="{E29A533F-18E3-A161-D707-B580921A187B}"/>
+                <a16:creationId xmlns:a16="http://schemas.microsoft.com/office/drawing/2014/main" id="{E0090F9E-E096-B864-72E3-26DB64B42ACA}"/>
               </a:ext>
             </a:extLst>
           </p:cNvPr>
@@ -921,7 +921,7 @@
           <a:bodyPr/>
           <a:lstStyle/>
           <a:p>
-            <a:fld id="{DD4C1154-42D3-4374-80F5-2BFDBA7E201F}" type="slidenum">
+            <a:fld id="{C4CCB2AA-4365-4CE6-A0E4-B3B886E50B42}" type="slidenum">
               <a:rPr lang="zh-CN" altLang="en-US" smtClean="0"/>
               <a:t>‹#›</a:t>
             </a:fld>
@@ -932,7 +932,7 @@
     </p:spTree>
     <p:extLst>
       <p:ext uri="{BB962C8B-B14F-4D97-AF65-F5344CB8AC3E}">
-        <p14:creationId xmlns:p14="http://schemas.microsoft.com/office/powerpoint/2010/main" val="2885131541"/>
+        <p14:creationId xmlns:p14="http://schemas.microsoft.com/office/powerpoint/2010/main" val="1808072486"/>
       </p:ext>
     </p:extLst>
   </p:cSld>
@@ -964,7 +964,7 @@
           <p:cNvPr id="2" name="标题 1">
             <a:extLst>
               <a:ext uri="{FF2B5EF4-FFF2-40B4-BE49-F238E27FC236}">
-                <a16:creationId xmlns:a16="http://schemas.microsoft.com/office/drawing/2014/main" id="{98168708-FA88-C7EB-D537-D8AE1EA22D0C}"/>
+                <a16:creationId xmlns:a16="http://schemas.microsoft.com/office/drawing/2014/main" id="{4B6D536E-C8CD-F56F-6FA5-CA62D7CC9DA0}"/>
               </a:ext>
             </a:extLst>
           </p:cNvPr>
@@ -1001,7 +1001,7 @@
           <p:cNvPr id="3" name="文本占位符 2">
             <a:extLst>
               <a:ext uri="{FF2B5EF4-FFF2-40B4-BE49-F238E27FC236}">
-                <a16:creationId xmlns:a16="http://schemas.microsoft.com/office/drawing/2014/main" id="{51569A44-2D96-610A-2E8E-E463B6C2D924}"/>
+                <a16:creationId xmlns:a16="http://schemas.microsoft.com/office/drawing/2014/main" id="{F2FD11F4-58F3-C7EB-D15F-ECD229528D26}"/>
               </a:ext>
             </a:extLst>
           </p:cNvPr>
@@ -1126,7 +1126,7 @@
           <p:cNvPr id="4" name="日期占位符 3">
             <a:extLst>
               <a:ext uri="{FF2B5EF4-FFF2-40B4-BE49-F238E27FC236}">
-                <a16:creationId xmlns:a16="http://schemas.microsoft.com/office/drawing/2014/main" id="{F9FA3FBA-2D23-A052-F6B6-705A3DF5E66B}"/>
+                <a16:creationId xmlns:a16="http://schemas.microsoft.com/office/drawing/2014/main" id="{A65ADE8A-E043-7F58-AF96-B12E441F9A97}"/>
               </a:ext>
             </a:extLst>
           </p:cNvPr>
@@ -1142,7 +1142,7 @@
           <a:bodyPr/>
           <a:lstStyle/>
           <a:p>
-            <a:fld id="{0B445544-D620-40E2-91EB-0E889D68CA9F}" type="datetimeFigureOut">
+            <a:fld id="{385F2371-EB98-4558-954D-418B83EB5BE7}" type="datetimeFigureOut">
               <a:rPr lang="zh-CN" altLang="en-US" smtClean="0"/>
               <a:t>2026-05-23</a:t>
             </a:fld>
@@ -1155,7 +1155,7 @@
           <p:cNvPr id="5" name="页脚占位符 4">
             <a:extLst>
               <a:ext uri="{FF2B5EF4-FFF2-40B4-BE49-F238E27FC236}">
-                <a16:creationId xmlns:a16="http://schemas.microsoft.com/office/drawing/2014/main" id="{BCBF5378-9433-1EB5-50CE-766BA5B59173}"/>
+                <a16:creationId xmlns:a16="http://schemas.microsoft.com/office/drawing/2014/main" id="{ED7AA7A8-F2F2-751B-07BB-67DBE660F5C0}"/>
               </a:ext>
             </a:extLst>
           </p:cNvPr>
@@ -1180,7 +1180,7 @@
           <p:cNvPr id="6" name="灯片编号占位符 5">
             <a:extLst>
               <a:ext uri="{FF2B5EF4-FFF2-40B4-BE49-F238E27FC236}">
-                <a16:creationId xmlns:a16="http://schemas.microsoft.com/office/drawing/2014/main" id="{9AC0687E-AC2E-6057-6F26-B971A929D83C}"/>
+                <a16:creationId xmlns:a16="http://schemas.microsoft.com/office/drawing/2014/main" id="{BFD5CFC0-2167-7763-2D1E-765AFE787A9E}"/>
               </a:ext>
             </a:extLst>
           </p:cNvPr>
@@ -1196,7 +1196,7 @@
           <a:bodyPr/>
           <a:lstStyle/>
           <a:p>
-            <a:fld id="{DD4C1154-42D3-4374-80F5-2BFDBA7E201F}" type="slidenum">
+            <a:fld id="{C4CCB2AA-4365-4CE6-A0E4-B3B886E50B42}" type="slidenum">
               <a:rPr lang="zh-CN" altLang="en-US" smtClean="0"/>
               <a:t>‹#›</a:t>
             </a:fld>
@@ -1207,7 +1207,7 @@
     </p:spTree>
     <p:extLst>
       <p:ext uri="{BB962C8B-B14F-4D97-AF65-F5344CB8AC3E}">
-        <p14:creationId xmlns:p14="http://schemas.microsoft.com/office/powerpoint/2010/main" val="3398641873"/>
+        <p14:creationId xmlns:p14="http://schemas.microsoft.com/office/powerpoint/2010/main" val="2900755954"/>
       </p:ext>
     </p:extLst>
   </p:cSld>
@@ -1239,7 +1239,7 @@
           <p:cNvPr id="2" name="标题 1">
             <a:extLst>
               <a:ext uri="{FF2B5EF4-FFF2-40B4-BE49-F238E27FC236}">
-                <a16:creationId xmlns:a16="http://schemas.microsoft.com/office/drawing/2014/main" id="{55043D9E-65E5-12DF-BDED-A7D9D84960CA}"/>
+                <a16:creationId xmlns:a16="http://schemas.microsoft.com/office/drawing/2014/main" id="{B37D05C0-7C90-E06E-E79E-6C891D9211FB}"/>
               </a:ext>
             </a:extLst>
           </p:cNvPr>
@@ -1267,7 +1267,7 @@
           <p:cNvPr id="3" name="内容占位符 2">
             <a:extLst>
               <a:ext uri="{FF2B5EF4-FFF2-40B4-BE49-F238E27FC236}">
-                <a16:creationId xmlns:a16="http://schemas.microsoft.com/office/drawing/2014/main" id="{44440B7E-034F-0429-C40E-4045141E2394}"/>
+                <a16:creationId xmlns:a16="http://schemas.microsoft.com/office/drawing/2014/main" id="{BBAD1504-5CEC-97B2-0E11-197ABB63FA34}"/>
               </a:ext>
             </a:extLst>
           </p:cNvPr>
@@ -1329,7 +1329,7 @@
           <p:cNvPr id="4" name="内容占位符 3">
             <a:extLst>
               <a:ext uri="{FF2B5EF4-FFF2-40B4-BE49-F238E27FC236}">
-                <a16:creationId xmlns:a16="http://schemas.microsoft.com/office/drawing/2014/main" id="{596A517A-7F9F-EEC9-D3C1-FDBC1D05B498}"/>
+                <a16:creationId xmlns:a16="http://schemas.microsoft.com/office/drawing/2014/main" id="{29D06A10-09A0-F6D2-14A0-E53522EC91B9}"/>
               </a:ext>
             </a:extLst>
           </p:cNvPr>
@@ -1391,7 +1391,7 @@
           <p:cNvPr id="5" name="日期占位符 4">
             <a:extLst>
               <a:ext uri="{FF2B5EF4-FFF2-40B4-BE49-F238E27FC236}">
-                <a16:creationId xmlns:a16="http://schemas.microsoft.com/office/drawing/2014/main" id="{AD38DE38-AECF-BBD9-4B6C-7E28962B859D}"/>
+                <a16:creationId xmlns:a16="http://schemas.microsoft.com/office/drawing/2014/main" id="{DAE24D9B-09ED-83C5-3496-69567B8646D0}"/>
               </a:ext>
             </a:extLst>
           </p:cNvPr>
@@ -1407,7 +1407,7 @@
           <a:bodyPr/>
           <a:lstStyle/>
           <a:p>
-            <a:fld id="{0B445544-D620-40E2-91EB-0E889D68CA9F}" type="datetimeFigureOut">
+            <a:fld id="{385F2371-EB98-4558-954D-418B83EB5BE7}" type="datetimeFigureOut">
               <a:rPr lang="zh-CN" altLang="en-US" smtClean="0"/>
               <a:t>2026-05-23</a:t>
             </a:fld>
@@ -1420,7 +1420,7 @@
           <p:cNvPr id="6" name="页脚占位符 5">
             <a:extLst>
               <a:ext uri="{FF2B5EF4-FFF2-40B4-BE49-F238E27FC236}">
-                <a16:creationId xmlns:a16="http://schemas.microsoft.com/office/drawing/2014/main" id="{7DC1A61C-9004-DFEE-C239-8FFD367E297D}"/>
+                <a16:creationId xmlns:a16="http://schemas.microsoft.com/office/drawing/2014/main" id="{9C36ACF7-4393-EC36-7A5C-19D1DB5523B7}"/>
               </a:ext>
             </a:extLst>
           </p:cNvPr>
@@ -1445,7 +1445,7 @@
           <p:cNvPr id="7" name="灯片编号占位符 6">
             <a:extLst>
               <a:ext uri="{FF2B5EF4-FFF2-40B4-BE49-F238E27FC236}">
-                <a16:creationId xmlns:a16="http://schemas.microsoft.com/office/drawing/2014/main" id="{AD6298B3-A295-B92C-7E2A-0B4BCABFFD35}"/>
+                <a16:creationId xmlns:a16="http://schemas.microsoft.com/office/drawing/2014/main" id="{8E19EB6C-979B-5E77-9AFC-EE7BE0CEEEC1}"/>
               </a:ext>
             </a:extLst>
           </p:cNvPr>
@@ -1461,7 +1461,7 @@
           <a:bodyPr/>
           <a:lstStyle/>
           <a:p>
-            <a:fld id="{DD4C1154-42D3-4374-80F5-2BFDBA7E201F}" type="slidenum">
+            <a:fld id="{C4CCB2AA-4365-4CE6-A0E4-B3B886E50B42}" type="slidenum">
               <a:rPr lang="zh-CN" altLang="en-US" smtClean="0"/>
               <a:t>‹#›</a:t>
             </a:fld>
@@ -1472,7 +1472,7 @@
     </p:spTree>
     <p:extLst>
       <p:ext uri="{BB962C8B-B14F-4D97-AF65-F5344CB8AC3E}">
-        <p14:creationId xmlns:p14="http://schemas.microsoft.com/office/powerpoint/2010/main" val="4011512523"/>
+        <p14:creationId xmlns:p14="http://schemas.microsoft.com/office/powerpoint/2010/main" val="468609685"/>
       </p:ext>
     </p:extLst>
   </p:cSld>
@@ -1504,7 +1504,7 @@
           <p:cNvPr id="2" name="标题 1">
             <a:extLst>
               <a:ext uri="{FF2B5EF4-FFF2-40B4-BE49-F238E27FC236}">
-                <a16:creationId xmlns:a16="http://schemas.microsoft.com/office/drawing/2014/main" id="{85CC726A-1125-6E22-E849-9328BB32C3C4}"/>
+                <a16:creationId xmlns:a16="http://schemas.microsoft.com/office/drawing/2014/main" id="{8D6CFE07-C4B8-974F-F111-60DF7BECF48A}"/>
               </a:ext>
             </a:extLst>
           </p:cNvPr>
@@ -1537,7 +1537,7 @@
           <p:cNvPr id="3" name="文本占位符 2">
             <a:extLst>
               <a:ext uri="{FF2B5EF4-FFF2-40B4-BE49-F238E27FC236}">
-                <a16:creationId xmlns:a16="http://schemas.microsoft.com/office/drawing/2014/main" id="{AC2D649B-F2FE-8B5C-54AA-4D618350A890}"/>
+                <a16:creationId xmlns:a16="http://schemas.microsoft.com/office/drawing/2014/main" id="{26DC8D5D-50EF-DD41-FD3D-0D73E6369FF2}"/>
               </a:ext>
             </a:extLst>
           </p:cNvPr>
@@ -1608,7 +1608,7 @@
           <p:cNvPr id="4" name="内容占位符 3">
             <a:extLst>
               <a:ext uri="{FF2B5EF4-FFF2-40B4-BE49-F238E27FC236}">
-                <a16:creationId xmlns:a16="http://schemas.microsoft.com/office/drawing/2014/main" id="{28C7CC20-1A35-E8DE-62FD-B6394C992A0E}"/>
+                <a16:creationId xmlns:a16="http://schemas.microsoft.com/office/drawing/2014/main" id="{AB9CF3A1-86A4-F21B-C602-8057F3809505}"/>
               </a:ext>
             </a:extLst>
           </p:cNvPr>
@@ -1670,7 +1670,7 @@
           <p:cNvPr id="5" name="文本占位符 4">
             <a:extLst>
               <a:ext uri="{FF2B5EF4-FFF2-40B4-BE49-F238E27FC236}">
-                <a16:creationId xmlns:a16="http://schemas.microsoft.com/office/drawing/2014/main" id="{ECBF29CA-192E-57DC-06B1-6C2337123B55}"/>
+                <a16:creationId xmlns:a16="http://schemas.microsoft.com/office/drawing/2014/main" id="{84566965-C097-BE1F-91CB-54ECDB06D6F1}"/>
               </a:ext>
             </a:extLst>
           </p:cNvPr>
@@ -1741,7 +1741,7 @@
           <p:cNvPr id="6" name="内容占位符 5">
             <a:extLst>
               <a:ext uri="{FF2B5EF4-FFF2-40B4-BE49-F238E27FC236}">
-                <a16:creationId xmlns:a16="http://schemas.microsoft.com/office/drawing/2014/main" id="{621730F4-4050-9B25-7DD8-8ED00D2A7D45}"/>
+                <a16:creationId xmlns:a16="http://schemas.microsoft.com/office/drawing/2014/main" id="{C2596303-FC2B-BCA3-DA6E-CB7AE6366E76}"/>
               </a:ext>
             </a:extLst>
           </p:cNvPr>
@@ -1803,7 +1803,7 @@
           <p:cNvPr id="7" name="日期占位符 6">
             <a:extLst>
               <a:ext uri="{FF2B5EF4-FFF2-40B4-BE49-F238E27FC236}">
-                <a16:creationId xmlns:a16="http://schemas.microsoft.com/office/drawing/2014/main" id="{71FE0314-99CD-BDE1-8602-989F10628932}"/>
+                <a16:creationId xmlns:a16="http://schemas.microsoft.com/office/drawing/2014/main" id="{4247B4C6-2502-39EB-28AD-1F22EDE22C77}"/>
               </a:ext>
             </a:extLst>
           </p:cNvPr>
@@ -1819,7 +1819,7 @@
           <a:bodyPr/>
           <a:lstStyle/>
           <a:p>
-            <a:fld id="{0B445544-D620-40E2-91EB-0E889D68CA9F}" type="datetimeFigureOut">
+            <a:fld id="{385F2371-EB98-4558-954D-418B83EB5BE7}" type="datetimeFigureOut">
               <a:rPr lang="zh-CN" altLang="en-US" smtClean="0"/>
               <a:t>2026-05-23</a:t>
             </a:fld>
@@ -1832,7 +1832,7 @@
           <p:cNvPr id="8" name="页脚占位符 7">
             <a:extLst>
               <a:ext uri="{FF2B5EF4-FFF2-40B4-BE49-F238E27FC236}">
-                <a16:creationId xmlns:a16="http://schemas.microsoft.com/office/drawing/2014/main" id="{63C2C58F-7B6C-F5D7-2DDE-DAA834C69035}"/>
+                <a16:creationId xmlns:a16="http://schemas.microsoft.com/office/drawing/2014/main" id="{2BCEE811-99AF-4649-8094-39E40B6523AB}"/>
               </a:ext>
             </a:extLst>
           </p:cNvPr>
@@ -1857,7 +1857,7 @@
           <p:cNvPr id="9" name="灯片编号占位符 8">
             <a:extLst>
               <a:ext uri="{FF2B5EF4-FFF2-40B4-BE49-F238E27FC236}">
-                <a16:creationId xmlns:a16="http://schemas.microsoft.com/office/drawing/2014/main" id="{35930FC2-08C7-4D4B-DDFD-714DB2F310E0}"/>
+                <a16:creationId xmlns:a16="http://schemas.microsoft.com/office/drawing/2014/main" id="{2F314CA9-63CB-BB0E-5FE2-F47C2EA0757E}"/>
               </a:ext>
             </a:extLst>
           </p:cNvPr>
@@ -1873,7 +1873,7 @@
           <a:bodyPr/>
           <a:lstStyle/>
           <a:p>
-            <a:fld id="{DD4C1154-42D3-4374-80F5-2BFDBA7E201F}" type="slidenum">
+            <a:fld id="{C4CCB2AA-4365-4CE6-A0E4-B3B886E50B42}" type="slidenum">
               <a:rPr lang="zh-CN" altLang="en-US" smtClean="0"/>
               <a:t>‹#›</a:t>
             </a:fld>
@@ -1884,7 +1884,7 @@
     </p:spTree>
     <p:extLst>
       <p:ext uri="{BB962C8B-B14F-4D97-AF65-F5344CB8AC3E}">
-        <p14:creationId xmlns:p14="http://schemas.microsoft.com/office/powerpoint/2010/main" val="2351826037"/>
+        <p14:creationId xmlns:p14="http://schemas.microsoft.com/office/powerpoint/2010/main" val="2748709209"/>
       </p:ext>
     </p:extLst>
   </p:cSld>
@@ -1916,7 +1916,7 @@
           <p:cNvPr id="2" name="标题 1">
             <a:extLst>
               <a:ext uri="{FF2B5EF4-FFF2-40B4-BE49-F238E27FC236}">
-                <a16:creationId xmlns:a16="http://schemas.microsoft.com/office/drawing/2014/main" id="{5824188E-75A6-A605-4214-3F0C139ED3CE}"/>
+                <a16:creationId xmlns:a16="http://schemas.microsoft.com/office/drawing/2014/main" id="{A9C189D0-B852-7827-E471-F40B9932EA14}"/>
               </a:ext>
             </a:extLst>
           </p:cNvPr>
@@ -1944,7 +1944,7 @@
           <p:cNvPr id="3" name="日期占位符 2">
             <a:extLst>
               <a:ext uri="{FF2B5EF4-FFF2-40B4-BE49-F238E27FC236}">
-                <a16:creationId xmlns:a16="http://schemas.microsoft.com/office/drawing/2014/main" id="{CA9E1384-B4FD-6F2E-E320-5D27B2ED539B}"/>
+                <a16:creationId xmlns:a16="http://schemas.microsoft.com/office/drawing/2014/main" id="{7E26AD88-FCE7-0445-5CC2-3C59F2361405}"/>
               </a:ext>
             </a:extLst>
           </p:cNvPr>
@@ -1960,7 +1960,7 @@
           <a:bodyPr/>
           <a:lstStyle/>
           <a:p>
-            <a:fld id="{0B445544-D620-40E2-91EB-0E889D68CA9F}" type="datetimeFigureOut">
+            <a:fld id="{385F2371-EB98-4558-954D-418B83EB5BE7}" type="datetimeFigureOut">
               <a:rPr lang="zh-CN" altLang="en-US" smtClean="0"/>
               <a:t>2026-05-23</a:t>
             </a:fld>
@@ -1973,7 +1973,7 @@
           <p:cNvPr id="4" name="页脚占位符 3">
             <a:extLst>
               <a:ext uri="{FF2B5EF4-FFF2-40B4-BE49-F238E27FC236}">
-                <a16:creationId xmlns:a16="http://schemas.microsoft.com/office/drawing/2014/main" id="{EC63F8C5-813A-0C11-B5B5-DA85F984ED59}"/>
+                <a16:creationId xmlns:a16="http://schemas.microsoft.com/office/drawing/2014/main" id="{5D558860-B90C-46D2-0DCE-73C958444599}"/>
               </a:ext>
             </a:extLst>
           </p:cNvPr>
@@ -1998,7 +1998,7 @@
           <p:cNvPr id="5" name="灯片编号占位符 4">
             <a:extLst>
               <a:ext uri="{FF2B5EF4-FFF2-40B4-BE49-F238E27FC236}">
-                <a16:creationId xmlns:a16="http://schemas.microsoft.com/office/drawing/2014/main" id="{13BCB9F1-5466-A067-8513-36A0283676EA}"/>
+                <a16:creationId xmlns:a16="http://schemas.microsoft.com/office/drawing/2014/main" id="{8609D60C-8C31-6B24-B7AE-7C76DBC19776}"/>
               </a:ext>
             </a:extLst>
           </p:cNvPr>
@@ -2014,7 +2014,7 @@
           <a:bodyPr/>
           <a:lstStyle/>
           <a:p>
-            <a:fld id="{DD4C1154-42D3-4374-80F5-2BFDBA7E201F}" type="slidenum">
+            <a:fld id="{C4CCB2AA-4365-4CE6-A0E4-B3B886E50B42}" type="slidenum">
               <a:rPr lang="zh-CN" altLang="en-US" smtClean="0"/>
               <a:t>‹#›</a:t>
             </a:fld>
@@ -2025,7 +2025,7 @@
     </p:spTree>
     <p:extLst>
       <p:ext uri="{BB962C8B-B14F-4D97-AF65-F5344CB8AC3E}">
-        <p14:creationId xmlns:p14="http://schemas.microsoft.com/office/powerpoint/2010/main" val="2442800634"/>
+        <p14:creationId xmlns:p14="http://schemas.microsoft.com/office/powerpoint/2010/main" val="910055477"/>
       </p:ext>
     </p:extLst>
   </p:cSld>
@@ -2057,7 +2057,7 @@
           <p:cNvPr id="2" name="日期占位符 1">
             <a:extLst>
               <a:ext uri="{FF2B5EF4-FFF2-40B4-BE49-F238E27FC236}">
-                <a16:creationId xmlns:a16="http://schemas.microsoft.com/office/drawing/2014/main" id="{B52E0FEA-BBCB-4DB3-7381-F0F27146CDE6}"/>
+                <a16:creationId xmlns:a16="http://schemas.microsoft.com/office/drawing/2014/main" id="{9E3068DC-E003-B079-77FF-CC34820D892B}"/>
               </a:ext>
             </a:extLst>
           </p:cNvPr>
@@ -2073,7 +2073,7 @@
           <a:bodyPr/>
           <a:lstStyle/>
           <a:p>
-            <a:fld id="{0B445544-D620-40E2-91EB-0E889D68CA9F}" type="datetimeFigureOut">
+            <a:fld id="{385F2371-EB98-4558-954D-418B83EB5BE7}" type="datetimeFigureOut">
               <a:rPr lang="zh-CN" altLang="en-US" smtClean="0"/>
               <a:t>2026-05-23</a:t>
             </a:fld>
@@ -2086,7 +2086,7 @@
           <p:cNvPr id="3" name="页脚占位符 2">
             <a:extLst>
               <a:ext uri="{FF2B5EF4-FFF2-40B4-BE49-F238E27FC236}">
-                <a16:creationId xmlns:a16="http://schemas.microsoft.com/office/drawing/2014/main" id="{694E80A5-006B-F6EF-62A4-6B24301A3560}"/>
+                <a16:creationId xmlns:a16="http://schemas.microsoft.com/office/drawing/2014/main" id="{241FF1D4-7317-8106-54C2-58DC3C84E8D1}"/>
               </a:ext>
             </a:extLst>
           </p:cNvPr>
@@ -2111,7 +2111,7 @@
           <p:cNvPr id="4" name="灯片编号占位符 3">
             <a:extLst>
               <a:ext uri="{FF2B5EF4-FFF2-40B4-BE49-F238E27FC236}">
-                <a16:creationId xmlns:a16="http://schemas.microsoft.com/office/drawing/2014/main" id="{FD57ABFA-7926-398E-8830-9C643D5DB148}"/>
+                <a16:creationId xmlns:a16="http://schemas.microsoft.com/office/drawing/2014/main" id="{390F454B-2254-C5F5-3A3D-EB2F32C9D22E}"/>
               </a:ext>
             </a:extLst>
           </p:cNvPr>
@@ -2127,7 +2127,7 @@
           <a:bodyPr/>
           <a:lstStyle/>
           <a:p>
-            <a:fld id="{DD4C1154-42D3-4374-80F5-2BFDBA7E201F}" type="slidenum">
+            <a:fld id="{C4CCB2AA-4365-4CE6-A0E4-B3B886E50B42}" type="slidenum">
               <a:rPr lang="zh-CN" altLang="en-US" smtClean="0"/>
               <a:t>‹#›</a:t>
             </a:fld>
@@ -2138,7 +2138,7 @@
     </p:spTree>
     <p:extLst>
       <p:ext uri="{BB962C8B-B14F-4D97-AF65-F5344CB8AC3E}">
-        <p14:creationId xmlns:p14="http://schemas.microsoft.com/office/powerpoint/2010/main" val="1063208581"/>
+        <p14:creationId xmlns:p14="http://schemas.microsoft.com/office/powerpoint/2010/main" val="93047603"/>
       </p:ext>
     </p:extLst>
   </p:cSld>
@@ -2170,7 +2170,7 @@
           <p:cNvPr id="2" name="标题 1">
             <a:extLst>
               <a:ext uri="{FF2B5EF4-FFF2-40B4-BE49-F238E27FC236}">
-                <a16:creationId xmlns:a16="http://schemas.microsoft.com/office/drawing/2014/main" id="{EF29F0B1-2788-AA06-8BFC-7BBB78469D2F}"/>
+                <a16:creationId xmlns:a16="http://schemas.microsoft.com/office/drawing/2014/main" id="{54FBF80A-B273-218D-99B2-AFF72CD81818}"/>
               </a:ext>
             </a:extLst>
           </p:cNvPr>
@@ -2207,7 +2207,7 @@
           <p:cNvPr id="3" name="内容占位符 2">
             <a:extLst>
               <a:ext uri="{FF2B5EF4-FFF2-40B4-BE49-F238E27FC236}">
-                <a16:creationId xmlns:a16="http://schemas.microsoft.com/office/drawing/2014/main" id="{2308709E-6123-B6AD-B796-06228EB909FB}"/>
+                <a16:creationId xmlns:a16="http://schemas.microsoft.com/office/drawing/2014/main" id="{D51DBB0A-75DF-D4B1-37FC-E28F4D72C2A9}"/>
               </a:ext>
             </a:extLst>
           </p:cNvPr>
@@ -2297,7 +2297,7 @@
           <p:cNvPr id="4" name="文本占位符 3">
             <a:extLst>
               <a:ext uri="{FF2B5EF4-FFF2-40B4-BE49-F238E27FC236}">
-                <a16:creationId xmlns:a16="http://schemas.microsoft.com/office/drawing/2014/main" id="{C2E4BACA-E204-D3D1-5781-035D92B1A7A0}"/>
+                <a16:creationId xmlns:a16="http://schemas.microsoft.com/office/drawing/2014/main" id="{2549B82A-4018-0CB0-75FA-89210A492765}"/>
               </a:ext>
             </a:extLst>
           </p:cNvPr>
@@ -2368,7 +2368,7 @@
           <p:cNvPr id="5" name="日期占位符 4">
             <a:extLst>
               <a:ext uri="{FF2B5EF4-FFF2-40B4-BE49-F238E27FC236}">
-                <a16:creationId xmlns:a16="http://schemas.microsoft.com/office/drawing/2014/main" id="{18E9D5F5-54D2-D8CB-505B-1D755B9D13E2}"/>
+                <a16:creationId xmlns:a16="http://schemas.microsoft.com/office/drawing/2014/main" id="{36791CED-D37F-BD8C-9D3D-BDBC954FD299}"/>
               </a:ext>
             </a:extLst>
           </p:cNvPr>
@@ -2384,7 +2384,7 @@
           <a:bodyPr/>
           <a:lstStyle/>
           <a:p>
-            <a:fld id="{0B445544-D620-40E2-91EB-0E889D68CA9F}" type="datetimeFigureOut">
+            <a:fld id="{385F2371-EB98-4558-954D-418B83EB5BE7}" type="datetimeFigureOut">
               <a:rPr lang="zh-CN" altLang="en-US" smtClean="0"/>
               <a:t>2026-05-23</a:t>
             </a:fld>
@@ -2397,7 +2397,7 @@
           <p:cNvPr id="6" name="页脚占位符 5">
             <a:extLst>
               <a:ext uri="{FF2B5EF4-FFF2-40B4-BE49-F238E27FC236}">
-                <a16:creationId xmlns:a16="http://schemas.microsoft.com/office/drawing/2014/main" id="{F3CE0E36-A3B4-EAF0-411C-E8785DE2E5B0}"/>
+                <a16:creationId xmlns:a16="http://schemas.microsoft.com/office/drawing/2014/main" id="{7A756B01-8F32-8D33-C6BC-B05CA849574F}"/>
               </a:ext>
             </a:extLst>
           </p:cNvPr>
@@ -2422,7 +2422,7 @@
           <p:cNvPr id="7" name="灯片编号占位符 6">
             <a:extLst>
               <a:ext uri="{FF2B5EF4-FFF2-40B4-BE49-F238E27FC236}">
-                <a16:creationId xmlns:a16="http://schemas.microsoft.com/office/drawing/2014/main" id="{6BEFFE8F-2073-6420-F14B-861590CE3144}"/>
+                <a16:creationId xmlns:a16="http://schemas.microsoft.com/office/drawing/2014/main" id="{90A3E2A7-60B9-596E-ADDA-D396CE0BE09E}"/>
               </a:ext>
             </a:extLst>
           </p:cNvPr>
@@ -2438,7 +2438,7 @@
           <a:bodyPr/>
           <a:lstStyle/>
           <a:p>
-            <a:fld id="{DD4C1154-42D3-4374-80F5-2BFDBA7E201F}" type="slidenum">
+            <a:fld id="{C4CCB2AA-4365-4CE6-A0E4-B3B886E50B42}" type="slidenum">
               <a:rPr lang="zh-CN" altLang="en-US" smtClean="0"/>
               <a:t>‹#›</a:t>
             </a:fld>
@@ -2449,7 +2449,7 @@
     </p:spTree>
     <p:extLst>
       <p:ext uri="{BB962C8B-B14F-4D97-AF65-F5344CB8AC3E}">
-        <p14:creationId xmlns:p14="http://schemas.microsoft.com/office/powerpoint/2010/main" val="1274536600"/>
+        <p14:creationId xmlns:p14="http://schemas.microsoft.com/office/powerpoint/2010/main" val="2928254655"/>
       </p:ext>
     </p:extLst>
   </p:cSld>
@@ -2481,7 +2481,7 @@
           <p:cNvPr id="2" name="标题 1">
             <a:extLst>
               <a:ext uri="{FF2B5EF4-FFF2-40B4-BE49-F238E27FC236}">
-                <a16:creationId xmlns:a16="http://schemas.microsoft.com/office/drawing/2014/main" id="{FDC5CCD3-F04E-4D77-5F7A-65E238D6138E}"/>
+                <a16:creationId xmlns:a16="http://schemas.microsoft.com/office/drawing/2014/main" id="{96CECF21-5760-23E6-B812-7271738D3FF1}"/>
               </a:ext>
             </a:extLst>
           </p:cNvPr>
@@ -2518,7 +2518,7 @@
           <p:cNvPr id="3" name="图片占位符 2">
             <a:extLst>
               <a:ext uri="{FF2B5EF4-FFF2-40B4-BE49-F238E27FC236}">
-                <a16:creationId xmlns:a16="http://schemas.microsoft.com/office/drawing/2014/main" id="{3C663AC4-E50D-D42D-350F-894A19B30DF3}"/>
+                <a16:creationId xmlns:a16="http://schemas.microsoft.com/office/drawing/2014/main" id="{00792171-707B-F9BD-E4E0-808F78EB7339}"/>
               </a:ext>
             </a:extLst>
           </p:cNvPr>
@@ -2585,7 +2585,7 @@
           <p:cNvPr id="4" name="文本占位符 3">
             <a:extLst>
               <a:ext uri="{FF2B5EF4-FFF2-40B4-BE49-F238E27FC236}">
-                <a16:creationId xmlns:a16="http://schemas.microsoft.com/office/drawing/2014/main" id="{135C2ED6-E741-F207-D449-1132E78B5C7C}"/>
+                <a16:creationId xmlns:a16="http://schemas.microsoft.com/office/drawing/2014/main" id="{9304B731-AA43-DC4D-1186-3DF5C9311D54}"/>
               </a:ext>
             </a:extLst>
           </p:cNvPr>
@@ -2656,7 +2656,7 @@
           <p:cNvPr id="5" name="日期占位符 4">
             <a:extLst>
               <a:ext uri="{FF2B5EF4-FFF2-40B4-BE49-F238E27FC236}">
-                <a16:creationId xmlns:a16="http://schemas.microsoft.com/office/drawing/2014/main" id="{F9F7132C-5394-06A1-880F-058E56F65559}"/>
+                <a16:creationId xmlns:a16="http://schemas.microsoft.com/office/drawing/2014/main" id="{24F3D765-4090-2D20-194B-2013BA81CBA3}"/>
               </a:ext>
             </a:extLst>
           </p:cNvPr>
@@ -2672,7 +2672,7 @@
           <a:bodyPr/>
           <a:lstStyle/>
           <a:p>
-            <a:fld id="{0B445544-D620-40E2-91EB-0E889D68CA9F}" type="datetimeFigureOut">
+            <a:fld id="{385F2371-EB98-4558-954D-418B83EB5BE7}" type="datetimeFigureOut">
               <a:rPr lang="zh-CN" altLang="en-US" smtClean="0"/>
               <a:t>2026-05-23</a:t>
             </a:fld>
@@ -2685,7 +2685,7 @@
           <p:cNvPr id="6" name="页脚占位符 5">
             <a:extLst>
               <a:ext uri="{FF2B5EF4-FFF2-40B4-BE49-F238E27FC236}">
-                <a16:creationId xmlns:a16="http://schemas.microsoft.com/office/drawing/2014/main" id="{6B1D0966-9C34-37CE-242E-6195BB864899}"/>
+                <a16:creationId xmlns:a16="http://schemas.microsoft.com/office/drawing/2014/main" id="{737EF83C-3B54-2179-B804-C44E6BE3523F}"/>
               </a:ext>
             </a:extLst>
           </p:cNvPr>
@@ -2710,7 +2710,7 @@
           <p:cNvPr id="7" name="灯片编号占位符 6">
             <a:extLst>
               <a:ext uri="{FF2B5EF4-FFF2-40B4-BE49-F238E27FC236}">
-                <a16:creationId xmlns:a16="http://schemas.microsoft.com/office/drawing/2014/main" id="{30DD7BD2-06D2-F51E-3536-DF7E4767227F}"/>
+                <a16:creationId xmlns:a16="http://schemas.microsoft.com/office/drawing/2014/main" id="{CCC60252-58DB-507B-47BA-9FD9C7D7D17B}"/>
               </a:ext>
             </a:extLst>
           </p:cNvPr>
@@ -2726,7 +2726,7 @@
           <a:bodyPr/>
           <a:lstStyle/>
           <a:p>
-            <a:fld id="{DD4C1154-42D3-4374-80F5-2BFDBA7E201F}" type="slidenum">
+            <a:fld id="{C4CCB2AA-4365-4CE6-A0E4-B3B886E50B42}" type="slidenum">
               <a:rPr lang="zh-CN" altLang="en-US" smtClean="0"/>
               <a:t>‹#›</a:t>
             </a:fld>
@@ -2737,7 +2737,7 @@
     </p:spTree>
     <p:extLst>
       <p:ext uri="{BB962C8B-B14F-4D97-AF65-F5344CB8AC3E}">
-        <p14:creationId xmlns:p14="http://schemas.microsoft.com/office/powerpoint/2010/main" val="1656186978"/>
+        <p14:creationId xmlns:p14="http://schemas.microsoft.com/office/powerpoint/2010/main" val="1136849433"/>
       </p:ext>
     </p:extLst>
   </p:cSld>
@@ -2774,7 +2774,7 @@
           <p:cNvPr id="2" name="标题占位符 1">
             <a:extLst>
               <a:ext uri="{FF2B5EF4-FFF2-40B4-BE49-F238E27FC236}">
-                <a16:creationId xmlns:a16="http://schemas.microsoft.com/office/drawing/2014/main" id="{429BD039-435D-C91C-C768-CAED80665506}"/>
+                <a16:creationId xmlns:a16="http://schemas.microsoft.com/office/drawing/2014/main" id="{81243787-2C0E-0102-804C-FF7C559DAAE3}"/>
               </a:ext>
             </a:extLst>
           </p:cNvPr>
@@ -2812,7 +2812,7 @@
           <p:cNvPr id="3" name="文本占位符 2">
             <a:extLst>
               <a:ext uri="{FF2B5EF4-FFF2-40B4-BE49-F238E27FC236}">
-                <a16:creationId xmlns:a16="http://schemas.microsoft.com/office/drawing/2014/main" id="{5EF632A5-ED28-EFD9-9E80-1420DE7753D0}"/>
+                <a16:creationId xmlns:a16="http://schemas.microsoft.com/office/drawing/2014/main" id="{55C54D86-D433-9AB9-C496-76FE265B07D2}"/>
               </a:ext>
             </a:extLst>
           </p:cNvPr>
@@ -2879,7 +2879,7 @@
           <p:cNvPr id="4" name="日期占位符 3">
             <a:extLst>
               <a:ext uri="{FF2B5EF4-FFF2-40B4-BE49-F238E27FC236}">
-                <a16:creationId xmlns:a16="http://schemas.microsoft.com/office/drawing/2014/main" id="{8BF1C33E-9E7A-8390-6670-05C22BC73D35}"/>
+                <a16:creationId xmlns:a16="http://schemas.microsoft.com/office/drawing/2014/main" id="{9C2DF595-AE4B-4D07-12C7-483C664F1486}"/>
               </a:ext>
             </a:extLst>
           </p:cNvPr>
@@ -2913,7 +2913,7 @@
             </a:lvl1pPr>
           </a:lstStyle>
           <a:p>
-            <a:fld id="{0B445544-D620-40E2-91EB-0E889D68CA9F}" type="datetimeFigureOut">
+            <a:fld id="{385F2371-EB98-4558-954D-418B83EB5BE7}" type="datetimeFigureOut">
               <a:rPr lang="zh-CN" altLang="en-US" smtClean="0"/>
               <a:t>2026-05-23</a:t>
             </a:fld>
@@ -2926,7 +2926,7 @@
           <p:cNvPr id="5" name="页脚占位符 4">
             <a:extLst>
               <a:ext uri="{FF2B5EF4-FFF2-40B4-BE49-F238E27FC236}">
-                <a16:creationId xmlns:a16="http://schemas.microsoft.com/office/drawing/2014/main" id="{95342CF5-1F8C-FB64-B4BE-CDCD77149534}"/>
+                <a16:creationId xmlns:a16="http://schemas.microsoft.com/office/drawing/2014/main" id="{514A26CA-3EE5-1AC7-2C6D-D20317C29BE8}"/>
               </a:ext>
             </a:extLst>
           </p:cNvPr>
@@ -2969,7 +2969,7 @@
           <p:cNvPr id="6" name="灯片编号占位符 5">
             <a:extLst>
               <a:ext uri="{FF2B5EF4-FFF2-40B4-BE49-F238E27FC236}">
-                <a16:creationId xmlns:a16="http://schemas.microsoft.com/office/drawing/2014/main" id="{8531B671-C89F-57A1-431C-5082F00235B7}"/>
+                <a16:creationId xmlns:a16="http://schemas.microsoft.com/office/drawing/2014/main" id="{AE43B4DF-111A-1107-E0AB-4E494AD0C74E}"/>
               </a:ext>
             </a:extLst>
           </p:cNvPr>
@@ -3003,7 +3003,7 @@
             </a:lvl1pPr>
           </a:lstStyle>
           <a:p>
-            <a:fld id="{DD4C1154-42D3-4374-80F5-2BFDBA7E201F}" type="slidenum">
+            <a:fld id="{C4CCB2AA-4365-4CE6-A0E4-B3B886E50B42}" type="slidenum">
               <a:rPr lang="zh-CN" altLang="en-US" smtClean="0"/>
               <a:t>‹#›</a:t>
             </a:fld>
@@ -3014,7 +3014,7 @@
     </p:spTree>
     <p:extLst>
       <p:ext uri="{BB962C8B-B14F-4D97-AF65-F5344CB8AC3E}">
-        <p14:creationId xmlns:p14="http://schemas.microsoft.com/office/powerpoint/2010/main" val="1458964103"/>
+        <p14:creationId xmlns:p14="http://schemas.microsoft.com/office/powerpoint/2010/main" val="2302296144"/>
       </p:ext>
     </p:extLst>
   </p:cSld>
@@ -3345,7 +3345,7 @@
           <p:cNvPr id="3" name="图片 2">
             <a:extLst>
               <a:ext uri="{FF2B5EF4-FFF2-40B4-BE49-F238E27FC236}">
-                <a16:creationId xmlns:a16="http://schemas.microsoft.com/office/drawing/2014/main" id="{FD969EC1-A3F8-B31C-575A-93B6CAF9CD29}"/>
+                <a16:creationId xmlns:a16="http://schemas.microsoft.com/office/drawing/2014/main" id="{12314D4B-08BE-E864-FE70-DBABDCE5E65C}"/>
               </a:ext>
             </a:extLst>
           </p:cNvPr>
@@ -3379,7 +3379,7 @@
     </p:spTree>
     <p:extLst>
       <p:ext uri="{BB962C8B-B14F-4D97-AF65-F5344CB8AC3E}">
-        <p14:creationId xmlns:p14="http://schemas.microsoft.com/office/powerpoint/2010/main" val="895396515"/>
+        <p14:creationId xmlns:p14="http://schemas.microsoft.com/office/powerpoint/2010/main" val="2831085619"/>
       </p:ext>
     </p:extLst>
   </p:cSld>
@@ -3388,10 +3388,10 @@
   </p:clrMapOvr>
   <mc:AlternateContent xmlns:mc="http://schemas.openxmlformats.org/markup-compatibility/2006">
     <mc:Choice xmlns:p14="http://schemas.microsoft.com/office/powerpoint/2010/main" Requires="p14">
-      <p:transition spd="slow" p14:dur="2000" advClick="0" advTm="20000"/>
+      <p:transition spd="slow" p14:dur="2000" advClick="0" advTm="18000"/>
     </mc:Choice>
     <mc:Fallback>
-      <p:transition spd="slow" advClick="0" advTm="20000"/>
+      <p:transition spd="slow" advClick="0" advTm="18000"/>
     </mc:Fallback>
   </mc:AlternateContent>
 </p:sld>
@@ -3427,7 +3427,7 @@
           <p:cNvPr id="3" name="图片 2">
             <a:extLst>
               <a:ext uri="{FF2B5EF4-FFF2-40B4-BE49-F238E27FC236}">
-                <a16:creationId xmlns:a16="http://schemas.microsoft.com/office/drawing/2014/main" id="{B8BC2A9A-F99B-EDEF-59BF-1D529BA8D50B}"/>
+                <a16:creationId xmlns:a16="http://schemas.microsoft.com/office/drawing/2014/main" id="{F7F5BA25-BF80-6F17-C455-C51CDE0E9CB4}"/>
               </a:ext>
             </a:extLst>
           </p:cNvPr>
@@ -3461,7 +3461,7 @@
     </p:spTree>
     <p:extLst>
       <p:ext uri="{BB962C8B-B14F-4D97-AF65-F5344CB8AC3E}">
-        <p14:creationId xmlns:p14="http://schemas.microsoft.com/office/powerpoint/2010/main" val="1981908477"/>
+        <p14:creationId xmlns:p14="http://schemas.microsoft.com/office/powerpoint/2010/main" val="1512644124"/>
       </p:ext>
     </p:extLst>
   </p:cSld>
@@ -3509,7 +3509,7 @@
           <p:cNvPr id="3" name="图片 2">
             <a:extLst>
               <a:ext uri="{FF2B5EF4-FFF2-40B4-BE49-F238E27FC236}">
-                <a16:creationId xmlns:a16="http://schemas.microsoft.com/office/drawing/2014/main" id="{AA74FA2B-218F-3808-87E0-ADC44A028A1E}"/>
+                <a16:creationId xmlns:a16="http://schemas.microsoft.com/office/drawing/2014/main" id="{187A075B-E17C-E9DD-AFC0-127323C7DF1B}"/>
               </a:ext>
             </a:extLst>
           </p:cNvPr>
@@ -3543,7 +3543,7 @@
     </p:spTree>
     <p:extLst>
       <p:ext uri="{BB962C8B-B14F-4D97-AF65-F5344CB8AC3E}">
-        <p14:creationId xmlns:p14="http://schemas.microsoft.com/office/powerpoint/2010/main" val="2234722691"/>
+        <p14:creationId xmlns:p14="http://schemas.microsoft.com/office/powerpoint/2010/main" val="145797113"/>
       </p:ext>
     </p:extLst>
   </p:cSld>
@@ -3552,10 +3552,10 @@
   </p:clrMapOvr>
   <mc:AlternateContent xmlns:mc="http://schemas.openxmlformats.org/markup-compatibility/2006">
     <mc:Choice xmlns:p14="http://schemas.microsoft.com/office/powerpoint/2010/main" Requires="p14">
-      <p:transition spd="slow" p14:dur="2000" advClick="0" advTm="15000"/>
+      <p:transition spd="slow" p14:dur="2000" advClick="0" advTm="14000"/>
     </mc:Choice>
     <mc:Fallback>
-      <p:transition spd="slow" advClick="0" advTm="15000"/>
+      <p:transition spd="slow" advClick="0" advTm="14000"/>
     </mc:Fallback>
   </mc:AlternateContent>
 </p:sld>
@@ -3591,7 +3591,7 @@
           <p:cNvPr id="3" name="图片 2">
             <a:extLst>
               <a:ext uri="{FF2B5EF4-FFF2-40B4-BE49-F238E27FC236}">
-                <a16:creationId xmlns:a16="http://schemas.microsoft.com/office/drawing/2014/main" id="{8D2234E3-4A7C-8DFA-F8C0-730D406CB20C}"/>
+                <a16:creationId xmlns:a16="http://schemas.microsoft.com/office/drawing/2014/main" id="{50B4610A-26FE-4CB7-346C-F4888524B47C}"/>
               </a:ext>
             </a:extLst>
           </p:cNvPr>
@@ -3625,7 +3625,7 @@
     </p:spTree>
     <p:extLst>
       <p:ext uri="{BB962C8B-B14F-4D97-AF65-F5344CB8AC3E}">
-        <p14:creationId xmlns:p14="http://schemas.microsoft.com/office/powerpoint/2010/main" val="1774210382"/>
+        <p14:creationId xmlns:p14="http://schemas.microsoft.com/office/powerpoint/2010/main" val="3352026383"/>
       </p:ext>
     </p:extLst>
   </p:cSld>
@@ -3673,7 +3673,7 @@
           <p:cNvPr id="3" name="图片 2">
             <a:extLst>
               <a:ext uri="{FF2B5EF4-FFF2-40B4-BE49-F238E27FC236}">
-                <a16:creationId xmlns:a16="http://schemas.microsoft.com/office/drawing/2014/main" id="{D52B3CB4-EFDE-3A52-180A-DEB30C659D5E}"/>
+                <a16:creationId xmlns:a16="http://schemas.microsoft.com/office/drawing/2014/main" id="{5978345A-C94A-EEFE-DE11-A2F48ADF1BC7}"/>
               </a:ext>
             </a:extLst>
           </p:cNvPr>
@@ -3707,7 +3707,7 @@
     </p:spTree>
     <p:extLst>
       <p:ext uri="{BB962C8B-B14F-4D97-AF65-F5344CB8AC3E}">
-        <p14:creationId xmlns:p14="http://schemas.microsoft.com/office/powerpoint/2010/main" val="1346648850"/>
+        <p14:creationId xmlns:p14="http://schemas.microsoft.com/office/powerpoint/2010/main" val="1765221618"/>
       </p:ext>
     </p:extLst>
   </p:cSld>
@@ -3716,10 +3716,10 @@
   </p:clrMapOvr>
   <mc:AlternateContent xmlns:mc="http://schemas.openxmlformats.org/markup-compatibility/2006">
     <mc:Choice xmlns:p14="http://schemas.microsoft.com/office/powerpoint/2010/main" Requires="p14">
-      <p:transition spd="slow" p14:dur="2000" advClick="0" advTm="15000"/>
+      <p:transition spd="slow" p14:dur="2000" advClick="0" advTm="14000"/>
     </mc:Choice>
     <mc:Fallback>
-      <p:transition spd="slow" advClick="0" advTm="15000"/>
+      <p:transition spd="slow" advClick="0" advTm="14000"/>
     </mc:Fallback>
   </mc:AlternateContent>
 </p:sld>
@@ -3755,7 +3755,7 @@
           <p:cNvPr id="3" name="图片 2">
             <a:extLst>
               <a:ext uri="{FF2B5EF4-FFF2-40B4-BE49-F238E27FC236}">
-                <a16:creationId xmlns:a16="http://schemas.microsoft.com/office/drawing/2014/main" id="{655A77DC-C511-1528-ADA8-800A886BA597}"/>
+                <a16:creationId xmlns:a16="http://schemas.microsoft.com/office/drawing/2014/main" id="{2F038789-3DDD-7C44-83F3-383BCB568A26}"/>
               </a:ext>
             </a:extLst>
           </p:cNvPr>
@@ -3789,7 +3789,7 @@
     </p:spTree>
     <p:extLst>
       <p:ext uri="{BB962C8B-B14F-4D97-AF65-F5344CB8AC3E}">
-        <p14:creationId xmlns:p14="http://schemas.microsoft.com/office/powerpoint/2010/main" val="542258904"/>
+        <p14:creationId xmlns:p14="http://schemas.microsoft.com/office/powerpoint/2010/main" val="3858565385"/>
       </p:ext>
     </p:extLst>
   </p:cSld>
@@ -3798,10 +3798,10 @@
   </p:clrMapOvr>
   <mc:AlternateContent xmlns:mc="http://schemas.openxmlformats.org/markup-compatibility/2006">
     <mc:Choice xmlns:p14="http://schemas.microsoft.com/office/powerpoint/2010/main" Requires="p14">
-      <p:transition spd="slow" p14:dur="2000" advClick="0" advTm="15000"/>
+      <p:transition spd="slow" p14:dur="2000" advClick="0" advTm="14000"/>
     </mc:Choice>
     <mc:Fallback>
-      <p:transition spd="slow" advClick="0" advTm="15000"/>
+      <p:transition spd="slow" advClick="0" advTm="14000"/>
     </mc:Fallback>
   </mc:AlternateContent>
 </p:sld>
@@ -3837,7 +3837,7 @@
           <p:cNvPr id="3" name="图片 2">
             <a:extLst>
               <a:ext uri="{FF2B5EF4-FFF2-40B4-BE49-F238E27FC236}">
-                <a16:creationId xmlns:a16="http://schemas.microsoft.com/office/drawing/2014/main" id="{355CF951-8FAD-7E08-B2EA-27F38FF7E7EF}"/>
+                <a16:creationId xmlns:a16="http://schemas.microsoft.com/office/drawing/2014/main" id="{D08C078A-56FA-DD16-5B51-F05D3B14999C}"/>
               </a:ext>
             </a:extLst>
           </p:cNvPr>
@@ -3871,7 +3871,7 @@
     </p:spTree>
     <p:extLst>
       <p:ext uri="{BB962C8B-B14F-4D97-AF65-F5344CB8AC3E}">
-        <p14:creationId xmlns:p14="http://schemas.microsoft.com/office/powerpoint/2010/main" val="1036320520"/>
+        <p14:creationId xmlns:p14="http://schemas.microsoft.com/office/powerpoint/2010/main" val="2037227412"/>
       </p:ext>
     </p:extLst>
   </p:cSld>
@@ -3880,10 +3880,10 @@
   </p:clrMapOvr>
   <mc:AlternateContent xmlns:mc="http://schemas.openxmlformats.org/markup-compatibility/2006">
     <mc:Choice xmlns:p14="http://schemas.microsoft.com/office/powerpoint/2010/main" Requires="p14">
-      <p:transition spd="slow" p14:dur="2000" advClick="0" advTm="15000"/>
+      <p:transition spd="slow" p14:dur="2000" advClick="0" advTm="14000"/>
     </mc:Choice>
     <mc:Fallback>
-      <p:transition spd="slow" advClick="0" advTm="15000"/>
+      <p:transition spd="slow" advClick="0" advTm="14000"/>
     </mc:Fallback>
   </mc:AlternateContent>
 </p:sld>
@@ -3919,7 +3919,7 @@
           <p:cNvPr id="3" name="图片 2">
             <a:extLst>
               <a:ext uri="{FF2B5EF4-FFF2-40B4-BE49-F238E27FC236}">
-                <a16:creationId xmlns:a16="http://schemas.microsoft.com/office/drawing/2014/main" id="{9882F0EE-78AA-BF27-66EA-ECDD0E9D0964}"/>
+                <a16:creationId xmlns:a16="http://schemas.microsoft.com/office/drawing/2014/main" id="{13DC5E92-53D3-6311-79FA-844C23636EE8}"/>
               </a:ext>
             </a:extLst>
           </p:cNvPr>
@@ -3953,7 +3953,7 @@
     </p:spTree>
     <p:extLst>
       <p:ext uri="{BB962C8B-B14F-4D97-AF65-F5344CB8AC3E}">
-        <p14:creationId xmlns:p14="http://schemas.microsoft.com/office/powerpoint/2010/main" val="2466800492"/>
+        <p14:creationId xmlns:p14="http://schemas.microsoft.com/office/powerpoint/2010/main" val="1996043838"/>
       </p:ext>
     </p:extLst>
   </p:cSld>
@@ -3962,10 +3962,10 @@
   </p:clrMapOvr>
   <mc:AlternateContent xmlns:mc="http://schemas.openxmlformats.org/markup-compatibility/2006">
     <mc:Choice xmlns:p14="http://schemas.microsoft.com/office/powerpoint/2010/main" Requires="p14">
-      <p:transition spd="slow" p14:dur="2000" advClick="0" advTm="18000"/>
+      <p:transition spd="slow" p14:dur="2000" advClick="0" advTm="17000"/>
     </mc:Choice>
     <mc:Fallback>
-      <p:transition spd="slow" advClick="0" advTm="18000"/>
+      <p:transition spd="slow" advClick="0" advTm="17000"/>
     </mc:Fallback>
   </mc:AlternateContent>
 </p:sld>
@@ -4001,7 +4001,7 @@
           <p:cNvPr id="3" name="图片 2">
             <a:extLst>
               <a:ext uri="{FF2B5EF4-FFF2-40B4-BE49-F238E27FC236}">
-                <a16:creationId xmlns:a16="http://schemas.microsoft.com/office/drawing/2014/main" id="{084B567B-5DB8-474E-1107-ABD65D519BDF}"/>
+                <a16:creationId xmlns:a16="http://schemas.microsoft.com/office/drawing/2014/main" id="{E7AFE154-B658-EF22-1344-B35B73755536}"/>
               </a:ext>
             </a:extLst>
           </p:cNvPr>
@@ -4035,7 +4035,7 @@
     </p:spTree>
     <p:extLst>
       <p:ext uri="{BB962C8B-B14F-4D97-AF65-F5344CB8AC3E}">
-        <p14:creationId xmlns:p14="http://schemas.microsoft.com/office/powerpoint/2010/main" val="837746117"/>
+        <p14:creationId xmlns:p14="http://schemas.microsoft.com/office/powerpoint/2010/main" val="623718495"/>
       </p:ext>
     </p:extLst>
   </p:cSld>
@@ -4044,10 +4044,10 @@
   </p:clrMapOvr>
   <mc:AlternateContent xmlns:mc="http://schemas.openxmlformats.org/markup-compatibility/2006">
     <mc:Choice xmlns:p14="http://schemas.microsoft.com/office/powerpoint/2010/main" Requires="p14">
-      <p:transition spd="slow" p14:dur="2000" advClick="0" advTm="18000"/>
+      <p:transition spd="slow" p14:dur="2000" advClick="0" advTm="17000"/>
     </mc:Choice>
     <mc:Fallback>
-      <p:transition spd="slow" advClick="0" advTm="18000"/>
+      <p:transition spd="slow" advClick="0" advTm="17000"/>
     </mc:Fallback>
   </mc:AlternateContent>
 </p:sld>
@@ -4083,7 +4083,7 @@
           <p:cNvPr id="3" name="图片 2">
             <a:extLst>
               <a:ext uri="{FF2B5EF4-FFF2-40B4-BE49-F238E27FC236}">
-                <a16:creationId xmlns:a16="http://schemas.microsoft.com/office/drawing/2014/main" id="{667ABBA1-24A3-17E4-0B7C-AF29C4FB4897}"/>
+                <a16:creationId xmlns:a16="http://schemas.microsoft.com/office/drawing/2014/main" id="{B5B57BDC-D4A4-EF22-F70F-2496D14D8797}"/>
               </a:ext>
             </a:extLst>
           </p:cNvPr>
@@ -4117,7 +4117,7 @@
     </p:spTree>
     <p:extLst>
       <p:ext uri="{BB962C8B-B14F-4D97-AF65-F5344CB8AC3E}">
-        <p14:creationId xmlns:p14="http://schemas.microsoft.com/office/powerpoint/2010/main" val="1782046534"/>
+        <p14:creationId xmlns:p14="http://schemas.microsoft.com/office/powerpoint/2010/main" val="1973860276"/>
       </p:ext>
     </p:extLst>
   </p:cSld>
@@ -4165,7 +4165,7 @@
           <p:cNvPr id="3" name="图片 2">
             <a:extLst>
               <a:ext uri="{FF2B5EF4-FFF2-40B4-BE49-F238E27FC236}">
-                <a16:creationId xmlns:a16="http://schemas.microsoft.com/office/drawing/2014/main" id="{1AC36E06-98A0-11AD-614C-9CFB9FAB4640}"/>
+                <a16:creationId xmlns:a16="http://schemas.microsoft.com/office/drawing/2014/main" id="{B7DD81EE-1521-4CB3-5AD4-CB48CB98E4C7}"/>
               </a:ext>
             </a:extLst>
           </p:cNvPr>
@@ -4199,7 +4199,7 @@
     </p:spTree>
     <p:extLst>
       <p:ext uri="{BB962C8B-B14F-4D97-AF65-F5344CB8AC3E}">
-        <p14:creationId xmlns:p14="http://schemas.microsoft.com/office/powerpoint/2010/main" val="2271598572"/>
+        <p14:creationId xmlns:p14="http://schemas.microsoft.com/office/powerpoint/2010/main" val="4249849013"/>
       </p:ext>
     </p:extLst>
   </p:cSld>
@@ -4247,7 +4247,7 @@
           <p:cNvPr id="3" name="图片 2">
             <a:extLst>
               <a:ext uri="{FF2B5EF4-FFF2-40B4-BE49-F238E27FC236}">
-                <a16:creationId xmlns:a16="http://schemas.microsoft.com/office/drawing/2014/main" id="{0A6514FB-7776-D7CE-F871-C9F536C0D3D3}"/>
+                <a16:creationId xmlns:a16="http://schemas.microsoft.com/office/drawing/2014/main" id="{53B4B304-17CB-66EC-8474-7BB15296BB6F}"/>
               </a:ext>
             </a:extLst>
           </p:cNvPr>
@@ -4281,7 +4281,7 @@
     </p:spTree>
     <p:extLst>
       <p:ext uri="{BB962C8B-B14F-4D97-AF65-F5344CB8AC3E}">
-        <p14:creationId xmlns:p14="http://schemas.microsoft.com/office/powerpoint/2010/main" val="1996070987"/>
+        <p14:creationId xmlns:p14="http://schemas.microsoft.com/office/powerpoint/2010/main" val="454049321"/>
       </p:ext>
     </p:extLst>
   </p:cSld>

</xml_diff>